<commit_message>
Final fit: direct-tuned x5 seeds + sensor-ceiling rule; sealed test 4.1% 3y downtime error
Sealed test (43 conveyors, spent once): dt_tot_pct 0.041, bias +14 h, P10-P90
coverage 0.825, t1/t5 log-error 0.631/0.259. 05 now scores ML-only and the
submitted tool (ML + expert rules). Slides carry team names.

Co-Authored-By: Claude Opus 5.5 <noreply@anthropic.com>
</commit_message>
<xml_diff>
--- a/outputs/Req1_slides.pptx
+++ b/outputs/Req1_slides.pptx
@@ -3352,7 +3352,7 @@
               </a:defRPr>
             </a:pPr>
             <a:r>
-              <a:t>TEAM MEMBER NAMES  ·  Industrial Conveyor Reliability Data Challenge  ·  fleet: 284 conveyors × 20 years</a:t>
+              <a:t>Zoltan Hegyi, Jose Acosta Aldrete  ·  Industrial Conveyor Reliability Data Challenge  ·  fleet: 284 conveyors × 20 years</a:t>
             </a:r>
           </a:p>
         </p:txBody>
@@ -3653,7 +3653,7 @@
               </a:defRPr>
             </a:pPr>
             <a:r>
-              <a:t>TEAM MEMBER NAMES  ·  Industrial Conveyor Reliability Data Challenge  ·  fleet: 284 conveyors × 20 years</a:t>
+              <a:t>Zoltan Hegyi, Jose Acosta Aldrete  ·  Industrial Conveyor Reliability Data Challenge  ·  fleet: 284 conveyors × 20 years</a:t>
             </a:r>
           </a:p>
         </p:txBody>

</xml_diff>